<commit_message>
feat(presentation): enlarge text and add prominent team members to slide 1
</commit_message>
<xml_diff>
--- a/Istikshaf_Executive_Presentation.pptx
+++ b/Istikshaf_Executive_Presentation.pptx
@@ -522,7 +522,7 @@
           </a:p>
           <a:p>
             <a:r>
-              <a:t>Judges and energy sector leaders: Every year, over 520 Billion Rupees vanishes from Pakistan's power grid into thin air. It is called Non-Technical Loss—power theft, illegal hookups, and meter tampering. It is the primary engine behind Pakistan's crippling 2.65 Trillion Rupee circular debt. Today, we present Istikshaf: an autonomous, physics-grounded enterprise AI platform that transforms revenue protection from blind manual spot-checks into precision enforcement.</a:t>
+              <a:t>Judges and energy sector leaders: Every year, over 520 Billion Rupees vanishes from Pakistan's power grid into thin air. It is called Non-Technical Loss—power theft, illegal hookups, and meter tampering. It is the primary engine behind Pakistan's crippling 2.65 Trillion Rupee circular debt. Today, our team—Hadiah Batool, Hashim Khushal Khan, Hamza Sultan, and Huda Ali—presents Istikshaf: an autonomous, physics-grounded enterprise AI platform that transforms revenue protection from blind manual spot-checks into precision enforcement.</a:t>
             </a:r>
           </a:p>
           <a:p/>
@@ -4960,8 +4960,8 @@
         </p:nvSpPr>
         <p:spPr>
           <a:xfrm>
-            <a:off x="731520" y="914400"/>
-            <a:ext cx="10728655" cy="36576"/>
+            <a:off x="731520" y="777240"/>
+            <a:ext cx="10728655" cy="45720"/>
           </a:xfrm>
           <a:prstGeom prst="rect">
             <a:avLst/>
@@ -5003,8 +5003,8 @@
         </p:nvSpPr>
         <p:spPr>
           <a:xfrm>
-            <a:off x="731520" y="1188720"/>
-            <a:ext cx="10728655" cy="2011680"/>
+            <a:off x="731520" y="960120"/>
+            <a:ext cx="10728655" cy="2103120"/>
           </a:xfrm>
           <a:prstGeom prst="rect">
             <a:avLst/>
@@ -5012,13 +5012,13 @@
           <a:noFill/>
         </p:spPr>
         <p:txBody>
-          <a:bodyPr wrap="square">
+          <a:bodyPr wrap="square" lIns="0" tIns="0" rIns="0" bIns="0">
             <a:spAutoFit/>
           </a:bodyPr>
           <a:lstStyle/>
           <a:p>
             <a:pPr>
-              <a:defRPr sz="4400" b="1">
+              <a:defRPr sz="5000" b="1">
                 <a:solidFill>
                   <a:srgbClr val="B6F542"/>
                 </a:solidFill>
@@ -5034,9 +5034,9 @@
               <a:spcBef>
                 <a:spcPts val="800"/>
               </a:spcBef>
-              <a:defRPr sz="2200" b="1">
-                <a:solidFill>
-                  <a:srgbClr val="E1E4D2"/>
+              <a:defRPr sz="2400" b="1">
+                <a:solidFill>
+                  <a:srgbClr val="FFFFFF"/>
                 </a:solidFill>
                 <a:latin typeface="Trebuchet MS"/>
               </a:defRPr>
@@ -5050,15 +5050,15 @@
               <a:spcBef>
                 <a:spcPts val="600"/>
               </a:spcBef>
-              <a:defRPr sz="1300">
-                <a:solidFill>
-                  <a:srgbClr val="A0A891"/>
-                </a:solidFill>
-                <a:latin typeface="Segoe UI"/>
-              </a:defRPr>
-            </a:pPr>
-            <a:r>
-              <a:t>A Physics-Grounded Enterprise Intelligence Engine Defeating Non-Technical Losses across Pakistan's Power Grid</a:t>
+              <a:defRPr sz="1400">
+                <a:solidFill>
+                  <a:srgbClr val="E1E4D2"/>
+                </a:solidFill>
+                <a:latin typeface="Segoe UI"/>
+              </a:defRPr>
+            </a:pPr>
+            <a:r>
+              <a:t>Physics-Grounded Enterprise Intelligence Engine Defeating Non-Technical Losses across Pakistan's Power Grid</a:t>
             </a:r>
           </a:p>
         </p:txBody>
@@ -5071,8 +5071,8 @@
         </p:nvSpPr>
         <p:spPr>
           <a:xfrm>
-            <a:off x="731520" y="3657600"/>
-            <a:ext cx="3291840" cy="2103120"/>
+            <a:off x="731520" y="3291840"/>
+            <a:ext cx="3291840" cy="1737360"/>
           </a:xfrm>
           <a:prstGeom prst="roundRect">
             <a:avLst/>
@@ -5116,8 +5116,8 @@
         </p:nvSpPr>
         <p:spPr>
           <a:xfrm>
-            <a:off x="896112" y="3785616"/>
-            <a:ext cx="2962656" cy="1847088"/>
+            <a:off x="896112" y="3419856"/>
+            <a:ext cx="2962656" cy="1481328"/>
           </a:xfrm>
           <a:prstGeom prst="rect">
             <a:avLst/>
@@ -5155,7 +5155,7 @@
               </a:defRPr>
             </a:pPr>
             <a:r>
-              <a:t>NATIONAL CIRCULAR DEBT</a:t>
+              <a:t>CIRCULAR DEBT CRISIS</a:t>
             </a:r>
           </a:p>
           <a:p>
@@ -5171,7 +5171,7 @@
               </a:defRPr>
             </a:pPr>
             <a:r>
-              <a:t>Suffocating Pakistan's fiscal stability and CPPA liquidity</a:t>
+              <a:t>Suffocating national CPPA liquidity</a:t>
             </a:r>
           </a:p>
         </p:txBody>
@@ -5184,8 +5184,8 @@
         </p:nvSpPr>
         <p:spPr>
           <a:xfrm>
-            <a:off x="4389120" y="3657600"/>
-            <a:ext cx="3291840" cy="2103120"/>
+            <a:off x="4389120" y="3291840"/>
+            <a:ext cx="3291840" cy="1737360"/>
           </a:xfrm>
           <a:prstGeom prst="roundRect">
             <a:avLst/>
@@ -5229,8 +5229,8 @@
         </p:nvSpPr>
         <p:spPr>
           <a:xfrm>
-            <a:off x="4553712" y="3785616"/>
-            <a:ext cx="2962656" cy="1847088"/>
+            <a:off x="4553712" y="3419856"/>
+            <a:ext cx="2962656" cy="1481328"/>
           </a:xfrm>
           <a:prstGeom prst="rect">
             <a:avLst/>
@@ -5284,7 +5284,7 @@
               </a:defRPr>
             </a:pPr>
             <a:r>
-              <a:t>Stolen via kundas, meter bypasses, and billing fraud</a:t>
+              <a:t>Stolen via kundas &amp; meter bypasses</a:t>
             </a:r>
           </a:p>
         </p:txBody>
@@ -5297,8 +5297,8 @@
         </p:nvSpPr>
         <p:spPr>
           <a:xfrm>
-            <a:off x="8046720" y="3657600"/>
-            <a:ext cx="3413455" cy="2103120"/>
+            <a:off x="8046720" y="3291840"/>
+            <a:ext cx="3413455" cy="1737360"/>
           </a:xfrm>
           <a:prstGeom prst="roundRect">
             <a:avLst/>
@@ -5342,8 +5342,8 @@
         </p:nvSpPr>
         <p:spPr>
           <a:xfrm>
-            <a:off x="8211312" y="3785616"/>
-            <a:ext cx="3084271" cy="1847088"/>
+            <a:off x="8211312" y="3419856"/>
+            <a:ext cx="3084271" cy="1481328"/>
           </a:xfrm>
           <a:prstGeom prst="rect">
             <a:avLst/>
@@ -5381,7 +5381,7 @@
               </a:defRPr>
             </a:pPr>
             <a:r>
-              <a:t>FIELD RAID PRECISION MULTIPLIER</a:t>
+              <a:t>RAID PRECISION GAIN</a:t>
             </a:r>
           </a:p>
           <a:p>
@@ -5397,7 +5397,431 @@
               </a:defRPr>
             </a:pPr>
             <a:r>
-              <a:t>From 3.6% random spot checks to 69.7% targeted precision</a:t>
+              <a:t>From 3.6% to 69.7% targeted accuracy</a:t>
+            </a:r>
+          </a:p>
+        </p:txBody>
+      </p:sp>
+      <p:sp>
+        <p:nvSpPr>
+          <p:cNvPr id="11" name="TextBox 10"/>
+          <p:cNvSpPr txBox="1"/>
+          <p:nvPr/>
+        </p:nvSpPr>
+        <p:spPr>
+          <a:xfrm>
+            <a:off x="731520" y="5230368"/>
+            <a:ext cx="10728655" cy="320040"/>
+          </a:xfrm>
+          <a:prstGeom prst="rect">
+            <a:avLst/>
+          </a:prstGeom>
+          <a:noFill/>
+        </p:spPr>
+        <p:txBody>
+          <a:bodyPr wrap="none" lIns="0" tIns="0" rIns="0" bIns="0">
+            <a:spAutoFit/>
+          </a:bodyPr>
+          <a:lstStyle/>
+          <a:p>
+            <a:pPr>
+              <a:defRPr sz="1100" b="1">
+                <a:solidFill>
+                  <a:srgbClr val="B6F542"/>
+                </a:solidFill>
+                <a:latin typeface="Consolas"/>
+              </a:defRPr>
+            </a:pPr>
+            <a:r>
+              <a:t>CORE ENGINEERING &amp; RESEARCH TEAM</a:t>
+            </a:r>
+          </a:p>
+        </p:txBody>
+      </p:sp>
+      <p:sp>
+        <p:nvSpPr>
+          <p:cNvPr id="12" name="Rounded Rectangle 11"/>
+          <p:cNvSpPr/>
+          <p:nvPr/>
+        </p:nvSpPr>
+        <p:spPr>
+          <a:xfrm>
+            <a:off x="731520" y="5596128"/>
+            <a:ext cx="2544775" cy="868680"/>
+          </a:xfrm>
+          <a:prstGeom prst="roundRect">
+            <a:avLst/>
+          </a:prstGeom>
+          <a:solidFill>
+            <a:srgbClr val="1F2516"/>
+          </a:solidFill>
+          <a:ln w="12700">
+            <a:solidFill>
+              <a:srgbClr val="506432"/>
+            </a:solidFill>
+          </a:ln>
+        </p:spPr>
+        <p:style>
+          <a:lnRef idx="1">
+            <a:schemeClr val="accent1"/>
+          </a:lnRef>
+          <a:fillRef idx="3">
+            <a:schemeClr val="accent1"/>
+          </a:fillRef>
+          <a:effectRef idx="2">
+            <a:schemeClr val="accent1"/>
+          </a:effectRef>
+          <a:fontRef idx="minor">
+            <a:schemeClr val="lt1"/>
+          </a:fontRef>
+        </p:style>
+        <p:txBody>
+          <a:bodyPr rtlCol="0" anchor="ctr"/>
+          <a:lstStyle/>
+          <a:p>
+            <a:pPr algn="ctr"/>
+          </a:p>
+        </p:txBody>
+      </p:sp>
+      <p:sp>
+        <p:nvSpPr>
+          <p:cNvPr id="13" name="TextBox 12"/>
+          <p:cNvSpPr txBox="1"/>
+          <p:nvPr/>
+        </p:nvSpPr>
+        <p:spPr>
+          <a:xfrm>
+            <a:off x="877824" y="5724144"/>
+            <a:ext cx="2252167" cy="612648"/>
+          </a:xfrm>
+          <a:prstGeom prst="rect">
+            <a:avLst/>
+          </a:prstGeom>
+          <a:noFill/>
+        </p:spPr>
+        <p:txBody>
+          <a:bodyPr wrap="square" lIns="0" tIns="0" rIns="0" bIns="0">
+            <a:spAutoFit/>
+          </a:bodyPr>
+          <a:lstStyle/>
+          <a:p>
+            <a:pPr>
+              <a:defRPr sz="1400" b="1">
+                <a:solidFill>
+                  <a:srgbClr val="FFFFFF"/>
+                </a:solidFill>
+                <a:latin typeface="Trebuchet MS"/>
+              </a:defRPr>
+            </a:pPr>
+            <a:r>
+              <a:t>Hadiah Batool</a:t>
+            </a:r>
+          </a:p>
+          <a:p>
+            <a:pPr>
+              <a:spcBef>
+                <a:spcPts val="400"/>
+              </a:spcBef>
+              <a:defRPr sz="900" b="1">
+                <a:solidFill>
+                  <a:srgbClr val="45DCEB"/>
+                </a:solidFill>
+                <a:latin typeface="Consolas"/>
+              </a:defRPr>
+            </a:pPr>
+            <a:r>
+              <a:t>CORE ML &amp; RESEARCH</a:t>
+            </a:r>
+          </a:p>
+        </p:txBody>
+      </p:sp>
+      <p:sp>
+        <p:nvSpPr>
+          <p:cNvPr id="14" name="Rounded Rectangle 13"/>
+          <p:cNvSpPr/>
+          <p:nvPr/>
+        </p:nvSpPr>
+        <p:spPr>
+          <a:xfrm>
+            <a:off x="3459175" y="5596128"/>
+            <a:ext cx="2544775" cy="868680"/>
+          </a:xfrm>
+          <a:prstGeom prst="roundRect">
+            <a:avLst/>
+          </a:prstGeom>
+          <a:solidFill>
+            <a:srgbClr val="1F2516"/>
+          </a:solidFill>
+          <a:ln w="12700">
+            <a:solidFill>
+              <a:srgbClr val="506432"/>
+            </a:solidFill>
+          </a:ln>
+        </p:spPr>
+        <p:style>
+          <a:lnRef idx="1">
+            <a:schemeClr val="accent1"/>
+          </a:lnRef>
+          <a:fillRef idx="3">
+            <a:schemeClr val="accent1"/>
+          </a:fillRef>
+          <a:effectRef idx="2">
+            <a:schemeClr val="accent1"/>
+          </a:effectRef>
+          <a:fontRef idx="minor">
+            <a:schemeClr val="lt1"/>
+          </a:fontRef>
+        </p:style>
+        <p:txBody>
+          <a:bodyPr rtlCol="0" anchor="ctr"/>
+          <a:lstStyle/>
+          <a:p>
+            <a:pPr algn="ctr"/>
+          </a:p>
+        </p:txBody>
+      </p:sp>
+      <p:sp>
+        <p:nvSpPr>
+          <p:cNvPr id="15" name="TextBox 14"/>
+          <p:cNvSpPr txBox="1"/>
+          <p:nvPr/>
+        </p:nvSpPr>
+        <p:spPr>
+          <a:xfrm>
+            <a:off x="3605479" y="5724144"/>
+            <a:ext cx="2252167" cy="612648"/>
+          </a:xfrm>
+          <a:prstGeom prst="rect">
+            <a:avLst/>
+          </a:prstGeom>
+          <a:noFill/>
+        </p:spPr>
+        <p:txBody>
+          <a:bodyPr wrap="square" lIns="0" tIns="0" rIns="0" bIns="0">
+            <a:spAutoFit/>
+          </a:bodyPr>
+          <a:lstStyle/>
+          <a:p>
+            <a:pPr>
+              <a:defRPr sz="1400" b="1">
+                <a:solidFill>
+                  <a:srgbClr val="FFFFFF"/>
+                </a:solidFill>
+                <a:latin typeface="Trebuchet MS"/>
+              </a:defRPr>
+            </a:pPr>
+            <a:r>
+              <a:t>Hashim Khushal Khan</a:t>
+            </a:r>
+          </a:p>
+          <a:p>
+            <a:pPr>
+              <a:spcBef>
+                <a:spcPts val="400"/>
+              </a:spcBef>
+              <a:defRPr sz="900" b="1">
+                <a:solidFill>
+                  <a:srgbClr val="45DCEB"/>
+                </a:solidFill>
+                <a:latin typeface="Consolas"/>
+              </a:defRPr>
+            </a:pPr>
+            <a:r>
+              <a:t>GRID PHYSICS &amp; MODELING</a:t>
+            </a:r>
+          </a:p>
+        </p:txBody>
+      </p:sp>
+      <p:sp>
+        <p:nvSpPr>
+          <p:cNvPr id="16" name="Rounded Rectangle 15"/>
+          <p:cNvSpPr/>
+          <p:nvPr/>
+        </p:nvSpPr>
+        <p:spPr>
+          <a:xfrm>
+            <a:off x="6186830" y="5596128"/>
+            <a:ext cx="2544775" cy="868680"/>
+          </a:xfrm>
+          <a:prstGeom prst="roundRect">
+            <a:avLst/>
+          </a:prstGeom>
+          <a:solidFill>
+            <a:srgbClr val="1F2516"/>
+          </a:solidFill>
+          <a:ln w="12700">
+            <a:solidFill>
+              <a:srgbClr val="506432"/>
+            </a:solidFill>
+          </a:ln>
+        </p:spPr>
+        <p:style>
+          <a:lnRef idx="1">
+            <a:schemeClr val="accent1"/>
+          </a:lnRef>
+          <a:fillRef idx="3">
+            <a:schemeClr val="accent1"/>
+          </a:fillRef>
+          <a:effectRef idx="2">
+            <a:schemeClr val="accent1"/>
+          </a:effectRef>
+          <a:fontRef idx="minor">
+            <a:schemeClr val="lt1"/>
+          </a:fontRef>
+        </p:style>
+        <p:txBody>
+          <a:bodyPr rtlCol="0" anchor="ctr"/>
+          <a:lstStyle/>
+          <a:p>
+            <a:pPr algn="ctr"/>
+          </a:p>
+        </p:txBody>
+      </p:sp>
+      <p:sp>
+        <p:nvSpPr>
+          <p:cNvPr id="17" name="TextBox 16"/>
+          <p:cNvSpPr txBox="1"/>
+          <p:nvPr/>
+        </p:nvSpPr>
+        <p:spPr>
+          <a:xfrm>
+            <a:off x="6333134" y="5724144"/>
+            <a:ext cx="2252167" cy="612648"/>
+          </a:xfrm>
+          <a:prstGeom prst="rect">
+            <a:avLst/>
+          </a:prstGeom>
+          <a:noFill/>
+        </p:spPr>
+        <p:txBody>
+          <a:bodyPr wrap="square" lIns="0" tIns="0" rIns="0" bIns="0">
+            <a:spAutoFit/>
+          </a:bodyPr>
+          <a:lstStyle/>
+          <a:p>
+            <a:pPr>
+              <a:defRPr sz="1400" b="1">
+                <a:solidFill>
+                  <a:srgbClr val="FFFFFF"/>
+                </a:solidFill>
+                <a:latin typeface="Trebuchet MS"/>
+              </a:defRPr>
+            </a:pPr>
+            <a:r>
+              <a:t>Hamza Sultan</a:t>
+            </a:r>
+          </a:p>
+          <a:p>
+            <a:pPr>
+              <a:spcBef>
+                <a:spcPts val="400"/>
+              </a:spcBef>
+              <a:defRPr sz="900" b="1">
+                <a:solidFill>
+                  <a:srgbClr val="45DCEB"/>
+                </a:solidFill>
+                <a:latin typeface="Consolas"/>
+              </a:defRPr>
+            </a:pPr>
+            <a:r>
+              <a:t>SYSTEM &amp; AGENT ARCHITECTURE</a:t>
+            </a:r>
+          </a:p>
+        </p:txBody>
+      </p:sp>
+      <p:sp>
+        <p:nvSpPr>
+          <p:cNvPr id="18" name="Rounded Rectangle 17"/>
+          <p:cNvSpPr/>
+          <p:nvPr/>
+        </p:nvSpPr>
+        <p:spPr>
+          <a:xfrm>
+            <a:off x="8914485" y="5596128"/>
+            <a:ext cx="2544775" cy="868680"/>
+          </a:xfrm>
+          <a:prstGeom prst="roundRect">
+            <a:avLst/>
+          </a:prstGeom>
+          <a:solidFill>
+            <a:srgbClr val="1F2516"/>
+          </a:solidFill>
+          <a:ln w="12700">
+            <a:solidFill>
+              <a:srgbClr val="506432"/>
+            </a:solidFill>
+          </a:ln>
+        </p:spPr>
+        <p:style>
+          <a:lnRef idx="1">
+            <a:schemeClr val="accent1"/>
+          </a:lnRef>
+          <a:fillRef idx="3">
+            <a:schemeClr val="accent1"/>
+          </a:fillRef>
+          <a:effectRef idx="2">
+            <a:schemeClr val="accent1"/>
+          </a:effectRef>
+          <a:fontRef idx="minor">
+            <a:schemeClr val="lt1"/>
+          </a:fontRef>
+        </p:style>
+        <p:txBody>
+          <a:bodyPr rtlCol="0" anchor="ctr"/>
+          <a:lstStyle/>
+          <a:p>
+            <a:pPr algn="ctr"/>
+          </a:p>
+        </p:txBody>
+      </p:sp>
+      <p:sp>
+        <p:nvSpPr>
+          <p:cNvPr id="19" name="TextBox 18"/>
+          <p:cNvSpPr txBox="1"/>
+          <p:nvPr/>
+        </p:nvSpPr>
+        <p:spPr>
+          <a:xfrm>
+            <a:off x="9060789" y="5724144"/>
+            <a:ext cx="2252167" cy="612648"/>
+          </a:xfrm>
+          <a:prstGeom prst="rect">
+            <a:avLst/>
+          </a:prstGeom>
+          <a:noFill/>
+        </p:spPr>
+        <p:txBody>
+          <a:bodyPr wrap="square" lIns="0" tIns="0" rIns="0" bIns="0">
+            <a:spAutoFit/>
+          </a:bodyPr>
+          <a:lstStyle/>
+          <a:p>
+            <a:pPr>
+              <a:defRPr sz="1400" b="1">
+                <a:solidFill>
+                  <a:srgbClr val="FFFFFF"/>
+                </a:solidFill>
+                <a:latin typeface="Trebuchet MS"/>
+              </a:defRPr>
+            </a:pPr>
+            <a:r>
+              <a:t>Huda Ali</a:t>
+            </a:r>
+          </a:p>
+          <a:p>
+            <a:pPr>
+              <a:spcBef>
+                <a:spcPts val="400"/>
+              </a:spcBef>
+              <a:defRPr sz="900" b="1">
+                <a:solidFill>
+                  <a:srgbClr val="45DCEB"/>
+                </a:solidFill>
+                <a:latin typeface="Consolas"/>
+              </a:defRPr>
+            </a:pPr>
+            <a:r>
+              <a:t>DATA &amp; STREAMING PIPELINE</a:t>
             </a:r>
           </a:p>
         </p:txBody>
@@ -9381,6 +9805,31 @@
                 <a:latin typeface="Segoe UI"/>
               </a:rPr>
               <a:t>Audited, physics-grounded, and ready for 90-day pilot deployment on high-loss 11kV feeders.</a:t>
+            </a:r>
+          </a:p>
+          <a:p>
+            <a:pPr>
+              <a:spcBef>
+                <a:spcPts val="600"/>
+              </a:spcBef>
+              <a:defRPr sz="1050" b="1">
+                <a:solidFill>
+                  <a:srgbClr val="45DCEB"/>
+                </a:solidFill>
+                <a:latin typeface="Segoe UI"/>
+              </a:defRPr>
+            </a:pPr>
+            <a:r>
+              <a:t>• The Engineering Team: </a:t>
+            </a:r>
+            <a:r>
+              <a:rPr sz="950" b="0">
+                <a:solidFill>
+                  <a:srgbClr val="A0A891"/>
+                </a:solidFill>
+                <a:latin typeface="Segoe UI"/>
+              </a:rPr>
+              <a:t>Hadiah Batool, Hashim Khushal Khan, Hamza Sultan, Huda Ali.</a:t>
             </a:r>
           </a:p>
         </p:txBody>

</xml_diff>

<commit_message>
feat(presentation): add transmission line silhouette props to slide backgrounds
</commit_message>
<xml_diff>
--- a/Istikshaf_Executive_Presentation.pptx
+++ b/Istikshaf_Executive_Presentation.pptx
@@ -4909,12 +4909,20 @@
         <p:nvPr/>
       </p:nvGrpSpPr>
       <p:grpSpPr/>
-      <p:sp>
-        <p:nvSpPr>
-          <p:cNvPr id="2" name="Rectangle 1"/>
-          <p:cNvSpPr/>
-          <p:nvPr/>
-        </p:nvSpPr>
+      <p:pic>
+        <p:nvPicPr>
+          <p:cNvPr id="2" name="Picture 1" descr="bg_transmission_lines_deck.jpg"/>
+          <p:cNvPicPr>
+            <a:picLocks noChangeAspect="1"/>
+          </p:cNvPicPr>
+          <p:nvPr/>
+        </p:nvPicPr>
+        <p:blipFill>
+          <a:blip r:embed="rId2"/>
+          <a:stretch>
+            <a:fillRect/>
+          </a:stretch>
+        </p:blipFill>
         <p:spPr>
           <a:xfrm>
             <a:off x="0" y="0"/>
@@ -4923,35 +4931,8 @@
           <a:prstGeom prst="rect">
             <a:avLst/>
           </a:prstGeom>
-          <a:solidFill>
-            <a:srgbClr val="11150A"/>
-          </a:solidFill>
-          <a:ln>
-            <a:noFill/>
-          </a:ln>
-        </p:spPr>
-        <p:style>
-          <a:lnRef idx="1">
-            <a:schemeClr val="accent1"/>
-          </a:lnRef>
-          <a:fillRef idx="3">
-            <a:schemeClr val="accent1"/>
-          </a:fillRef>
-          <a:effectRef idx="2">
-            <a:schemeClr val="accent1"/>
-          </a:effectRef>
-          <a:fontRef idx="minor">
-            <a:schemeClr val="lt1"/>
-          </a:fontRef>
-        </p:style>
-        <p:txBody>
-          <a:bodyPr rtlCol="0" anchor="ctr"/>
-          <a:lstStyle/>
-          <a:p>
-            <a:pPr algn="ctr"/>
-          </a:p>
-        </p:txBody>
-      </p:sp>
+        </p:spPr>
+      </p:pic>
       <p:sp>
         <p:nvSpPr>
           <p:cNvPr id="3" name="Rectangle 2"/>
@@ -5844,12 +5825,20 @@
         <p:nvPr/>
       </p:nvGrpSpPr>
       <p:grpSpPr/>
-      <p:sp>
-        <p:nvSpPr>
-          <p:cNvPr id="2" name="Rectangle 1"/>
-          <p:cNvSpPr/>
-          <p:nvPr/>
-        </p:nvSpPr>
+      <p:pic>
+        <p:nvPicPr>
+          <p:cNvPr id="2" name="Picture 1" descr="bg_transmission_lines_deck.jpg"/>
+          <p:cNvPicPr>
+            <a:picLocks noChangeAspect="1"/>
+          </p:cNvPicPr>
+          <p:nvPr/>
+        </p:nvPicPr>
+        <p:blipFill>
+          <a:blip r:embed="rId2"/>
+          <a:stretch>
+            <a:fillRect/>
+          </a:stretch>
+        </p:blipFill>
         <p:spPr>
           <a:xfrm>
             <a:off x="0" y="0"/>
@@ -5858,35 +5847,8 @@
           <a:prstGeom prst="rect">
             <a:avLst/>
           </a:prstGeom>
-          <a:solidFill>
-            <a:srgbClr val="11150A"/>
-          </a:solidFill>
-          <a:ln>
-            <a:noFill/>
-          </a:ln>
-        </p:spPr>
-        <p:style>
-          <a:lnRef idx="1">
-            <a:schemeClr val="accent1"/>
-          </a:lnRef>
-          <a:fillRef idx="3">
-            <a:schemeClr val="accent1"/>
-          </a:fillRef>
-          <a:effectRef idx="2">
-            <a:schemeClr val="accent1"/>
-          </a:effectRef>
-          <a:fontRef idx="minor">
-            <a:schemeClr val="lt1"/>
-          </a:fontRef>
-        </p:style>
-        <p:txBody>
-          <a:bodyPr rtlCol="0" anchor="ctr"/>
-          <a:lstStyle/>
-          <a:p>
-            <a:pPr algn="ctr"/>
-          </a:p>
-        </p:txBody>
-      </p:sp>
+        </p:spPr>
+      </p:pic>
       <p:sp>
         <p:nvSpPr>
           <p:cNvPr id="3" name="TextBox 2"/>
@@ -6482,12 +6444,20 @@
         <p:nvPr/>
       </p:nvGrpSpPr>
       <p:grpSpPr/>
-      <p:sp>
-        <p:nvSpPr>
-          <p:cNvPr id="2" name="Rectangle 1"/>
-          <p:cNvSpPr/>
-          <p:nvPr/>
-        </p:nvSpPr>
+      <p:pic>
+        <p:nvPicPr>
+          <p:cNvPr id="2" name="Picture 1" descr="bg_transmission_lines_deck.jpg"/>
+          <p:cNvPicPr>
+            <a:picLocks noChangeAspect="1"/>
+          </p:cNvPicPr>
+          <p:nvPr/>
+        </p:nvPicPr>
+        <p:blipFill>
+          <a:blip r:embed="rId2"/>
+          <a:stretch>
+            <a:fillRect/>
+          </a:stretch>
+        </p:blipFill>
         <p:spPr>
           <a:xfrm>
             <a:off x="0" y="0"/>
@@ -6496,35 +6466,8 @@
           <a:prstGeom prst="rect">
             <a:avLst/>
           </a:prstGeom>
-          <a:solidFill>
-            <a:srgbClr val="11150A"/>
-          </a:solidFill>
-          <a:ln>
-            <a:noFill/>
-          </a:ln>
-        </p:spPr>
-        <p:style>
-          <a:lnRef idx="1">
-            <a:schemeClr val="accent1"/>
-          </a:lnRef>
-          <a:fillRef idx="3">
-            <a:schemeClr val="accent1"/>
-          </a:fillRef>
-          <a:effectRef idx="2">
-            <a:schemeClr val="accent1"/>
-          </a:effectRef>
-          <a:fontRef idx="minor">
-            <a:schemeClr val="lt1"/>
-          </a:fontRef>
-        </p:style>
-        <p:txBody>
-          <a:bodyPr rtlCol="0" anchor="ctr"/>
-          <a:lstStyle/>
-          <a:p>
-            <a:pPr algn="ctr"/>
-          </a:p>
-        </p:txBody>
-      </p:sp>
+        </p:spPr>
+      </p:pic>
       <p:sp>
         <p:nvSpPr>
           <p:cNvPr id="3" name="TextBox 2"/>
@@ -7175,12 +7118,20 @@
         <p:nvPr/>
       </p:nvGrpSpPr>
       <p:grpSpPr/>
-      <p:sp>
-        <p:nvSpPr>
-          <p:cNvPr id="2" name="Rectangle 1"/>
-          <p:cNvSpPr/>
-          <p:nvPr/>
-        </p:nvSpPr>
+      <p:pic>
+        <p:nvPicPr>
+          <p:cNvPr id="2" name="Picture 1" descr="bg_transmission_lines_deck.jpg"/>
+          <p:cNvPicPr>
+            <a:picLocks noChangeAspect="1"/>
+          </p:cNvPicPr>
+          <p:nvPr/>
+        </p:nvPicPr>
+        <p:blipFill>
+          <a:blip r:embed="rId2"/>
+          <a:stretch>
+            <a:fillRect/>
+          </a:stretch>
+        </p:blipFill>
         <p:spPr>
           <a:xfrm>
             <a:off x="0" y="0"/>
@@ -7189,11 +7140,137 @@
           <a:prstGeom prst="rect">
             <a:avLst/>
           </a:prstGeom>
+        </p:spPr>
+      </p:pic>
+      <p:sp>
+        <p:nvSpPr>
+          <p:cNvPr id="3" name="TextBox 2"/>
+          <p:cNvSpPr txBox="1"/>
+          <p:nvPr/>
+        </p:nvSpPr>
+        <p:spPr>
+          <a:xfrm>
+            <a:off x="731520" y="365760"/>
+            <a:ext cx="5486400" cy="320040"/>
+          </a:xfrm>
+          <a:prstGeom prst="rect">
+            <a:avLst/>
+          </a:prstGeom>
+          <a:noFill/>
+        </p:spPr>
+        <p:txBody>
+          <a:bodyPr wrap="square" lIns="0" tIns="0" rIns="0" bIns="0">
+            <a:spAutoFit/>
+          </a:bodyPr>
+          <a:lstStyle/>
+          <a:p>
+            <a:pPr>
+              <a:defRPr sz="950" b="1">
+                <a:solidFill>
+                  <a:srgbClr val="B6F542"/>
+                </a:solidFill>
+                <a:latin typeface="Consolas"/>
+              </a:defRPr>
+            </a:pPr>
+            <a:r>
+              <a:t>BENCHMARK VERIFICATION</a:t>
+            </a:r>
+          </a:p>
+        </p:txBody>
+      </p:sp>
+      <p:sp>
+        <p:nvSpPr>
+          <p:cNvPr id="4" name="TextBox 3"/>
+          <p:cNvSpPr txBox="1"/>
+          <p:nvPr/>
+        </p:nvSpPr>
+        <p:spPr>
+          <a:xfrm>
+            <a:off x="731520" y="658368"/>
+            <a:ext cx="10698480" cy="594360"/>
+          </a:xfrm>
+          <a:prstGeom prst="rect">
+            <a:avLst/>
+          </a:prstGeom>
+          <a:noFill/>
+        </p:spPr>
+        <p:txBody>
+          <a:bodyPr wrap="square" lIns="0" tIns="0" rIns="0" bIns="0">
+            <a:spAutoFit/>
+          </a:bodyPr>
+          <a:lstStyle/>
+          <a:p>
+            <a:pPr>
+              <a:defRPr sz="2200" b="1">
+                <a:solidFill>
+                  <a:srgbClr val="E1E4D2"/>
+                </a:solidFill>
+                <a:latin typeface="Trebuchet MS"/>
+              </a:defRPr>
+            </a:pPr>
+            <a:r>
+              <a:t>Proven Operational Uplift: 19.3x Precision &amp; 5.5x Peak Uplift</a:t>
+            </a:r>
+          </a:p>
+        </p:txBody>
+      </p:sp>
+      <p:sp>
+        <p:nvSpPr>
+          <p:cNvPr id="5" name="TextBox 4"/>
+          <p:cNvSpPr txBox="1"/>
+          <p:nvPr/>
+        </p:nvSpPr>
+        <p:spPr>
+          <a:xfrm>
+            <a:off x="731520" y="1243584"/>
+            <a:ext cx="10698480" cy="365760"/>
+          </a:xfrm>
+          <a:prstGeom prst="rect">
+            <a:avLst/>
+          </a:prstGeom>
+          <a:noFill/>
+        </p:spPr>
+        <p:txBody>
+          <a:bodyPr wrap="square" lIns="0" tIns="0" rIns="0" bIns="0">
+            <a:spAutoFit/>
+          </a:bodyPr>
+          <a:lstStyle/>
+          <a:p>
+            <a:pPr>
+              <a:defRPr sz="1100">
+                <a:solidFill>
+                  <a:srgbClr val="A0A891"/>
+                </a:solidFill>
+                <a:latin typeface="Segoe UI"/>
+              </a:defRPr>
+            </a:pPr>
+            <a:r>
+              <a:t>Rigorous out-of-sample evaluation on isolated 20% test splits across 72,000 consumer-months</a:t>
+            </a:r>
+          </a:p>
+        </p:txBody>
+      </p:sp>
+      <p:sp>
+        <p:nvSpPr>
+          <p:cNvPr id="6" name="Rounded Rectangle 5"/>
+          <p:cNvSpPr/>
+          <p:nvPr/>
+        </p:nvSpPr>
+        <p:spPr>
+          <a:xfrm>
+            <a:off x="731520" y="1691640"/>
+            <a:ext cx="4754880" cy="4572000"/>
+          </a:xfrm>
+          <a:prstGeom prst="roundRect">
+            <a:avLst/>
+          </a:prstGeom>
           <a:solidFill>
-            <a:srgbClr val="11150A"/>
+            <a:srgbClr val="181D11"/>
           </a:solidFill>
-          <a:ln>
-            <a:noFill/>
+          <a:ln w="12700">
+            <a:solidFill>
+              <a:srgbClr val="2E3523"/>
+            </a:solidFill>
           </a:ln>
         </p:spPr>
         <p:style>
@@ -7220,159 +7297,6 @@
       </p:sp>
       <p:sp>
         <p:nvSpPr>
-          <p:cNvPr id="3" name="TextBox 2"/>
-          <p:cNvSpPr txBox="1"/>
-          <p:nvPr/>
-        </p:nvSpPr>
-        <p:spPr>
-          <a:xfrm>
-            <a:off x="731520" y="365760"/>
-            <a:ext cx="5486400" cy="320040"/>
-          </a:xfrm>
-          <a:prstGeom prst="rect">
-            <a:avLst/>
-          </a:prstGeom>
-          <a:noFill/>
-        </p:spPr>
-        <p:txBody>
-          <a:bodyPr wrap="square" lIns="0" tIns="0" rIns="0" bIns="0">
-            <a:spAutoFit/>
-          </a:bodyPr>
-          <a:lstStyle/>
-          <a:p>
-            <a:pPr>
-              <a:defRPr sz="950" b="1">
-                <a:solidFill>
-                  <a:srgbClr val="B6F542"/>
-                </a:solidFill>
-                <a:latin typeface="Consolas"/>
-              </a:defRPr>
-            </a:pPr>
-            <a:r>
-              <a:t>BENCHMARK VERIFICATION</a:t>
-            </a:r>
-          </a:p>
-        </p:txBody>
-      </p:sp>
-      <p:sp>
-        <p:nvSpPr>
-          <p:cNvPr id="4" name="TextBox 3"/>
-          <p:cNvSpPr txBox="1"/>
-          <p:nvPr/>
-        </p:nvSpPr>
-        <p:spPr>
-          <a:xfrm>
-            <a:off x="731520" y="658368"/>
-            <a:ext cx="10698480" cy="594360"/>
-          </a:xfrm>
-          <a:prstGeom prst="rect">
-            <a:avLst/>
-          </a:prstGeom>
-          <a:noFill/>
-        </p:spPr>
-        <p:txBody>
-          <a:bodyPr wrap="square" lIns="0" tIns="0" rIns="0" bIns="0">
-            <a:spAutoFit/>
-          </a:bodyPr>
-          <a:lstStyle/>
-          <a:p>
-            <a:pPr>
-              <a:defRPr sz="2200" b="1">
-                <a:solidFill>
-                  <a:srgbClr val="E1E4D2"/>
-                </a:solidFill>
-                <a:latin typeface="Trebuchet MS"/>
-              </a:defRPr>
-            </a:pPr>
-            <a:r>
-              <a:t>Proven Operational Uplift: 19.3x Precision &amp; 5.5x Peak Uplift</a:t>
-            </a:r>
-          </a:p>
-        </p:txBody>
-      </p:sp>
-      <p:sp>
-        <p:nvSpPr>
-          <p:cNvPr id="5" name="TextBox 4"/>
-          <p:cNvSpPr txBox="1"/>
-          <p:nvPr/>
-        </p:nvSpPr>
-        <p:spPr>
-          <a:xfrm>
-            <a:off x="731520" y="1243584"/>
-            <a:ext cx="10698480" cy="365760"/>
-          </a:xfrm>
-          <a:prstGeom prst="rect">
-            <a:avLst/>
-          </a:prstGeom>
-          <a:noFill/>
-        </p:spPr>
-        <p:txBody>
-          <a:bodyPr wrap="square" lIns="0" tIns="0" rIns="0" bIns="0">
-            <a:spAutoFit/>
-          </a:bodyPr>
-          <a:lstStyle/>
-          <a:p>
-            <a:pPr>
-              <a:defRPr sz="1100">
-                <a:solidFill>
-                  <a:srgbClr val="A0A891"/>
-                </a:solidFill>
-                <a:latin typeface="Segoe UI"/>
-              </a:defRPr>
-            </a:pPr>
-            <a:r>
-              <a:t>Rigorous out-of-sample evaluation on isolated 20% test splits across 72,000 consumer-months</a:t>
-            </a:r>
-          </a:p>
-        </p:txBody>
-      </p:sp>
-      <p:sp>
-        <p:nvSpPr>
-          <p:cNvPr id="6" name="Rounded Rectangle 5"/>
-          <p:cNvSpPr/>
-          <p:nvPr/>
-        </p:nvSpPr>
-        <p:spPr>
-          <a:xfrm>
-            <a:off x="731520" y="1691640"/>
-            <a:ext cx="4754880" cy="4572000"/>
-          </a:xfrm>
-          <a:prstGeom prst="roundRect">
-            <a:avLst/>
-          </a:prstGeom>
-          <a:solidFill>
-            <a:srgbClr val="181D11"/>
-          </a:solidFill>
-          <a:ln w="12700">
-            <a:solidFill>
-              <a:srgbClr val="2E3523"/>
-            </a:solidFill>
-          </a:ln>
-        </p:spPr>
-        <p:style>
-          <a:lnRef idx="1">
-            <a:schemeClr val="accent1"/>
-          </a:lnRef>
-          <a:fillRef idx="3">
-            <a:schemeClr val="accent1"/>
-          </a:fillRef>
-          <a:effectRef idx="2">
-            <a:schemeClr val="accent1"/>
-          </a:effectRef>
-          <a:fontRef idx="minor">
-            <a:schemeClr val="lt1"/>
-          </a:fontRef>
-        </p:style>
-        <p:txBody>
-          <a:bodyPr rtlCol="0" anchor="ctr"/>
-          <a:lstStyle/>
-          <a:p>
-            <a:pPr algn="ctr"/>
-          </a:p>
-        </p:txBody>
-      </p:sp>
-      <p:sp>
-        <p:nvSpPr>
           <p:cNvPr id="7" name="TextBox 6"/>
           <p:cNvSpPr txBox="1"/>
           <p:nvPr/>
@@ -7516,7 +7440,7 @@
           <p:nvPr/>
         </p:nvPicPr>
         <p:blipFill>
-          <a:blip r:embed="rId2"/>
+          <a:blip r:embed="rId3"/>
           <a:stretch>
             <a:fillRect/>
           </a:stretch>
@@ -7549,12 +7473,20 @@
         <p:nvPr/>
       </p:nvGrpSpPr>
       <p:grpSpPr/>
-      <p:sp>
-        <p:nvSpPr>
-          <p:cNvPr id="2" name="Rectangle 1"/>
-          <p:cNvSpPr/>
-          <p:nvPr/>
-        </p:nvSpPr>
+      <p:pic>
+        <p:nvPicPr>
+          <p:cNvPr id="2" name="Picture 1" descr="bg_transmission_lines_deck.jpg"/>
+          <p:cNvPicPr>
+            <a:picLocks noChangeAspect="1"/>
+          </p:cNvPicPr>
+          <p:nvPr/>
+        </p:nvPicPr>
+        <p:blipFill>
+          <a:blip r:embed="rId2"/>
+          <a:stretch>
+            <a:fillRect/>
+          </a:stretch>
+        </p:blipFill>
         <p:spPr>
           <a:xfrm>
             <a:off x="0" y="0"/>
@@ -7563,35 +7495,8 @@
           <a:prstGeom prst="rect">
             <a:avLst/>
           </a:prstGeom>
-          <a:solidFill>
-            <a:srgbClr val="11150A"/>
-          </a:solidFill>
-          <a:ln>
-            <a:noFill/>
-          </a:ln>
-        </p:spPr>
-        <p:style>
-          <a:lnRef idx="1">
-            <a:schemeClr val="accent1"/>
-          </a:lnRef>
-          <a:fillRef idx="3">
-            <a:schemeClr val="accent1"/>
-          </a:fillRef>
-          <a:effectRef idx="2">
-            <a:schemeClr val="accent1"/>
-          </a:effectRef>
-          <a:fontRef idx="minor">
-            <a:schemeClr val="lt1"/>
-          </a:fontRef>
-        </p:style>
-        <p:txBody>
-          <a:bodyPr rtlCol="0" anchor="ctr"/>
-          <a:lstStyle/>
-          <a:p>
-            <a:pPr algn="ctr"/>
-          </a:p>
-        </p:txBody>
-      </p:sp>
+        </p:spPr>
+      </p:pic>
       <p:sp>
         <p:nvSpPr>
           <p:cNvPr id="3" name="TextBox 2"/>
@@ -8242,12 +8147,20 @@
         <p:nvPr/>
       </p:nvGrpSpPr>
       <p:grpSpPr/>
-      <p:sp>
-        <p:nvSpPr>
-          <p:cNvPr id="2" name="Rectangle 1"/>
-          <p:cNvSpPr/>
-          <p:nvPr/>
-        </p:nvSpPr>
+      <p:pic>
+        <p:nvPicPr>
+          <p:cNvPr id="2" name="Picture 1" descr="bg_transmission_lines_deck.jpg"/>
+          <p:cNvPicPr>
+            <a:picLocks noChangeAspect="1"/>
+          </p:cNvPicPr>
+          <p:nvPr/>
+        </p:nvPicPr>
+        <p:blipFill>
+          <a:blip r:embed="rId2"/>
+          <a:stretch>
+            <a:fillRect/>
+          </a:stretch>
+        </p:blipFill>
         <p:spPr>
           <a:xfrm>
             <a:off x="0" y="0"/>
@@ -8256,35 +8169,8 @@
           <a:prstGeom prst="rect">
             <a:avLst/>
           </a:prstGeom>
-          <a:solidFill>
-            <a:srgbClr val="11150A"/>
-          </a:solidFill>
-          <a:ln>
-            <a:noFill/>
-          </a:ln>
-        </p:spPr>
-        <p:style>
-          <a:lnRef idx="1">
-            <a:schemeClr val="accent1"/>
-          </a:lnRef>
-          <a:fillRef idx="3">
-            <a:schemeClr val="accent1"/>
-          </a:fillRef>
-          <a:effectRef idx="2">
-            <a:schemeClr val="accent1"/>
-          </a:effectRef>
-          <a:fontRef idx="minor">
-            <a:schemeClr val="lt1"/>
-          </a:fontRef>
-        </p:style>
-        <p:txBody>
-          <a:bodyPr rtlCol="0" anchor="ctr"/>
-          <a:lstStyle/>
-          <a:p>
-            <a:pPr algn="ctr"/>
-          </a:p>
-        </p:txBody>
-      </p:sp>
+        </p:spPr>
+      </p:pic>
       <p:sp>
         <p:nvSpPr>
           <p:cNvPr id="3" name="TextBox 2"/>
@@ -8815,12 +8701,20 @@
         <p:nvPr/>
       </p:nvGrpSpPr>
       <p:grpSpPr/>
-      <p:sp>
-        <p:nvSpPr>
-          <p:cNvPr id="2" name="Rectangle 1"/>
-          <p:cNvSpPr/>
-          <p:nvPr/>
-        </p:nvSpPr>
+      <p:pic>
+        <p:nvPicPr>
+          <p:cNvPr id="2" name="Picture 1" descr="bg_transmission_lines_deck.jpg"/>
+          <p:cNvPicPr>
+            <a:picLocks noChangeAspect="1"/>
+          </p:cNvPicPr>
+          <p:nvPr/>
+        </p:nvPicPr>
+        <p:blipFill>
+          <a:blip r:embed="rId2"/>
+          <a:stretch>
+            <a:fillRect/>
+          </a:stretch>
+        </p:blipFill>
         <p:spPr>
           <a:xfrm>
             <a:off x="0" y="0"/>
@@ -8829,35 +8723,8 @@
           <a:prstGeom prst="rect">
             <a:avLst/>
           </a:prstGeom>
-          <a:solidFill>
-            <a:srgbClr val="11150A"/>
-          </a:solidFill>
-          <a:ln>
-            <a:noFill/>
-          </a:ln>
-        </p:spPr>
-        <p:style>
-          <a:lnRef idx="1">
-            <a:schemeClr val="accent1"/>
-          </a:lnRef>
-          <a:fillRef idx="3">
-            <a:schemeClr val="accent1"/>
-          </a:fillRef>
-          <a:effectRef idx="2">
-            <a:schemeClr val="accent1"/>
-          </a:effectRef>
-          <a:fontRef idx="minor">
-            <a:schemeClr val="lt1"/>
-          </a:fontRef>
-        </p:style>
-        <p:txBody>
-          <a:bodyPr rtlCol="0" anchor="ctr"/>
-          <a:lstStyle/>
-          <a:p>
-            <a:pPr algn="ctr"/>
-          </a:p>
-        </p:txBody>
-      </p:sp>
+        </p:spPr>
+      </p:pic>
       <p:sp>
         <p:nvSpPr>
           <p:cNvPr id="3" name="TextBox 2"/>
@@ -9452,12 +9319,20 @@
         <p:nvPr/>
       </p:nvGrpSpPr>
       <p:grpSpPr/>
-      <p:sp>
-        <p:nvSpPr>
-          <p:cNvPr id="2" name="Rectangle 1"/>
-          <p:cNvSpPr/>
-          <p:nvPr/>
-        </p:nvSpPr>
+      <p:pic>
+        <p:nvPicPr>
+          <p:cNvPr id="2" name="Picture 1" descr="bg_transmission_lines_deck.jpg"/>
+          <p:cNvPicPr>
+            <a:picLocks noChangeAspect="1"/>
+          </p:cNvPicPr>
+          <p:nvPr/>
+        </p:nvPicPr>
+        <p:blipFill>
+          <a:blip r:embed="rId2"/>
+          <a:stretch>
+            <a:fillRect/>
+          </a:stretch>
+        </p:blipFill>
         <p:spPr>
           <a:xfrm>
             <a:off x="0" y="0"/>
@@ -9466,11 +9341,137 @@
           <a:prstGeom prst="rect">
             <a:avLst/>
           </a:prstGeom>
+        </p:spPr>
+      </p:pic>
+      <p:sp>
+        <p:nvSpPr>
+          <p:cNvPr id="3" name="TextBox 2"/>
+          <p:cNvSpPr txBox="1"/>
+          <p:nvPr/>
+        </p:nvSpPr>
+        <p:spPr>
+          <a:xfrm>
+            <a:off x="731520" y="365760"/>
+            <a:ext cx="5486400" cy="320040"/>
+          </a:xfrm>
+          <a:prstGeom prst="rect">
+            <a:avLst/>
+          </a:prstGeom>
+          <a:noFill/>
+        </p:spPr>
+        <p:txBody>
+          <a:bodyPr wrap="square" lIns="0" tIns="0" rIns="0" bIns="0">
+            <a:spAutoFit/>
+          </a:bodyPr>
+          <a:lstStyle/>
+          <a:p>
+            <a:pPr>
+              <a:defRPr sz="950" b="1">
+                <a:solidFill>
+                  <a:srgbClr val="B6F542"/>
+                </a:solidFill>
+                <a:latin typeface="Consolas"/>
+              </a:defRPr>
+            </a:pPr>
+            <a:r>
+              <a:t>BUSINESS CASE &amp; VERDICT</a:t>
+            </a:r>
+          </a:p>
+        </p:txBody>
+      </p:sp>
+      <p:sp>
+        <p:nvSpPr>
+          <p:cNvPr id="4" name="TextBox 3"/>
+          <p:cNvSpPr txBox="1"/>
+          <p:nvPr/>
+        </p:nvSpPr>
+        <p:spPr>
+          <a:xfrm>
+            <a:off x="731520" y="658368"/>
+            <a:ext cx="10698480" cy="594360"/>
+          </a:xfrm>
+          <a:prstGeom prst="rect">
+            <a:avLst/>
+          </a:prstGeom>
+          <a:noFill/>
+        </p:spPr>
+        <p:txBody>
+          <a:bodyPr wrap="square" lIns="0" tIns="0" rIns="0" bIns="0">
+            <a:spAutoFit/>
+          </a:bodyPr>
+          <a:lstStyle/>
+          <a:p>
+            <a:pPr>
+              <a:defRPr sz="2200" b="1">
+                <a:solidFill>
+                  <a:srgbClr val="E1E4D2"/>
+                </a:solidFill>
+                <a:latin typeface="Trebuchet MS"/>
+              </a:defRPr>
+            </a:pPr>
+            <a:r>
+              <a:t>Unlocking Billions: The DISCO ROI Model &amp; Sovereign Impact</a:t>
+            </a:r>
+          </a:p>
+        </p:txBody>
+      </p:sp>
+      <p:sp>
+        <p:nvSpPr>
+          <p:cNvPr id="5" name="TextBox 4"/>
+          <p:cNvSpPr txBox="1"/>
+          <p:nvPr/>
+        </p:nvSpPr>
+        <p:spPr>
+          <a:xfrm>
+            <a:off x="731520" y="1243584"/>
+            <a:ext cx="10698480" cy="365760"/>
+          </a:xfrm>
+          <a:prstGeom prst="rect">
+            <a:avLst/>
+          </a:prstGeom>
+          <a:noFill/>
+        </p:spPr>
+        <p:txBody>
+          <a:bodyPr wrap="square" lIns="0" tIns="0" rIns="0" bIns="0">
+            <a:spAutoFit/>
+          </a:bodyPr>
+          <a:lstStyle/>
+          <a:p>
+            <a:pPr>
+              <a:defRPr sz="1100">
+                <a:solidFill>
+                  <a:srgbClr val="A0A891"/>
+                </a:solidFill>
+                <a:latin typeface="Segoe UI"/>
+              </a:defRPr>
+            </a:pPr>
+            <a:r>
+              <a:t>Transforming utility balance sheets and securing Pakistan's energy future</a:t>
+            </a:r>
+          </a:p>
+        </p:txBody>
+      </p:sp>
+      <p:sp>
+        <p:nvSpPr>
+          <p:cNvPr id="6" name="Rounded Rectangle 5"/>
+          <p:cNvSpPr/>
+          <p:nvPr/>
+        </p:nvSpPr>
+        <p:spPr>
+          <a:xfrm>
+            <a:off x="731520" y="1691640"/>
+            <a:ext cx="4754880" cy="4572000"/>
+          </a:xfrm>
+          <a:prstGeom prst="roundRect">
+            <a:avLst/>
+          </a:prstGeom>
           <a:solidFill>
-            <a:srgbClr val="11150A"/>
+            <a:srgbClr val="181D11"/>
           </a:solidFill>
-          <a:ln>
-            <a:noFill/>
+          <a:ln w="12700">
+            <a:solidFill>
+              <a:srgbClr val="2E3523"/>
+            </a:solidFill>
           </a:ln>
         </p:spPr>
         <p:style>
@@ -9497,159 +9498,6 @@
       </p:sp>
       <p:sp>
         <p:nvSpPr>
-          <p:cNvPr id="3" name="TextBox 2"/>
-          <p:cNvSpPr txBox="1"/>
-          <p:nvPr/>
-        </p:nvSpPr>
-        <p:spPr>
-          <a:xfrm>
-            <a:off x="731520" y="365760"/>
-            <a:ext cx="5486400" cy="320040"/>
-          </a:xfrm>
-          <a:prstGeom prst="rect">
-            <a:avLst/>
-          </a:prstGeom>
-          <a:noFill/>
-        </p:spPr>
-        <p:txBody>
-          <a:bodyPr wrap="square" lIns="0" tIns="0" rIns="0" bIns="0">
-            <a:spAutoFit/>
-          </a:bodyPr>
-          <a:lstStyle/>
-          <a:p>
-            <a:pPr>
-              <a:defRPr sz="950" b="1">
-                <a:solidFill>
-                  <a:srgbClr val="B6F542"/>
-                </a:solidFill>
-                <a:latin typeface="Consolas"/>
-              </a:defRPr>
-            </a:pPr>
-            <a:r>
-              <a:t>BUSINESS CASE &amp; VERDICT</a:t>
-            </a:r>
-          </a:p>
-        </p:txBody>
-      </p:sp>
-      <p:sp>
-        <p:nvSpPr>
-          <p:cNvPr id="4" name="TextBox 3"/>
-          <p:cNvSpPr txBox="1"/>
-          <p:nvPr/>
-        </p:nvSpPr>
-        <p:spPr>
-          <a:xfrm>
-            <a:off x="731520" y="658368"/>
-            <a:ext cx="10698480" cy="594360"/>
-          </a:xfrm>
-          <a:prstGeom prst="rect">
-            <a:avLst/>
-          </a:prstGeom>
-          <a:noFill/>
-        </p:spPr>
-        <p:txBody>
-          <a:bodyPr wrap="square" lIns="0" tIns="0" rIns="0" bIns="0">
-            <a:spAutoFit/>
-          </a:bodyPr>
-          <a:lstStyle/>
-          <a:p>
-            <a:pPr>
-              <a:defRPr sz="2200" b="1">
-                <a:solidFill>
-                  <a:srgbClr val="E1E4D2"/>
-                </a:solidFill>
-                <a:latin typeface="Trebuchet MS"/>
-              </a:defRPr>
-            </a:pPr>
-            <a:r>
-              <a:t>Unlocking Billions: The DISCO ROI Model &amp; Sovereign Impact</a:t>
-            </a:r>
-          </a:p>
-        </p:txBody>
-      </p:sp>
-      <p:sp>
-        <p:nvSpPr>
-          <p:cNvPr id="5" name="TextBox 4"/>
-          <p:cNvSpPr txBox="1"/>
-          <p:nvPr/>
-        </p:nvSpPr>
-        <p:spPr>
-          <a:xfrm>
-            <a:off x="731520" y="1243584"/>
-            <a:ext cx="10698480" cy="365760"/>
-          </a:xfrm>
-          <a:prstGeom prst="rect">
-            <a:avLst/>
-          </a:prstGeom>
-          <a:noFill/>
-        </p:spPr>
-        <p:txBody>
-          <a:bodyPr wrap="square" lIns="0" tIns="0" rIns="0" bIns="0">
-            <a:spAutoFit/>
-          </a:bodyPr>
-          <a:lstStyle/>
-          <a:p>
-            <a:pPr>
-              <a:defRPr sz="1100">
-                <a:solidFill>
-                  <a:srgbClr val="A0A891"/>
-                </a:solidFill>
-                <a:latin typeface="Segoe UI"/>
-              </a:defRPr>
-            </a:pPr>
-            <a:r>
-              <a:t>Transforming utility balance sheets and securing Pakistan's energy future</a:t>
-            </a:r>
-          </a:p>
-        </p:txBody>
-      </p:sp>
-      <p:sp>
-        <p:nvSpPr>
-          <p:cNvPr id="6" name="Rounded Rectangle 5"/>
-          <p:cNvSpPr/>
-          <p:nvPr/>
-        </p:nvSpPr>
-        <p:spPr>
-          <a:xfrm>
-            <a:off x="731520" y="1691640"/>
-            <a:ext cx="4754880" cy="4572000"/>
-          </a:xfrm>
-          <a:prstGeom prst="roundRect">
-            <a:avLst/>
-          </a:prstGeom>
-          <a:solidFill>
-            <a:srgbClr val="181D11"/>
-          </a:solidFill>
-          <a:ln w="12700">
-            <a:solidFill>
-              <a:srgbClr val="2E3523"/>
-            </a:solidFill>
-          </a:ln>
-        </p:spPr>
-        <p:style>
-          <a:lnRef idx="1">
-            <a:schemeClr val="accent1"/>
-          </a:lnRef>
-          <a:fillRef idx="3">
-            <a:schemeClr val="accent1"/>
-          </a:fillRef>
-          <a:effectRef idx="2">
-            <a:schemeClr val="accent1"/>
-          </a:effectRef>
-          <a:fontRef idx="minor">
-            <a:schemeClr val="lt1"/>
-          </a:fontRef>
-        </p:style>
-        <p:txBody>
-          <a:bodyPr rtlCol="0" anchor="ctr"/>
-          <a:lstStyle/>
-          <a:p>
-            <a:pPr algn="ctr"/>
-          </a:p>
-        </p:txBody>
-      </p:sp>
-      <p:sp>
-        <p:nvSpPr>
           <p:cNvPr id="7" name="TextBox 6"/>
           <p:cNvSpPr txBox="1"/>
           <p:nvPr/>
@@ -9843,7 +9691,7 @@
           <p:nvPr/>
         </p:nvPicPr>
         <p:blipFill>
-          <a:blip r:embed="rId2"/>
+          <a:blip r:embed="rId3"/>
           <a:stretch>
             <a:fillRect/>
           </a:stretch>
@@ -9876,12 +9724,20 @@
         <p:nvPr/>
       </p:nvGrpSpPr>
       <p:grpSpPr/>
-      <p:sp>
-        <p:nvSpPr>
-          <p:cNvPr id="2" name="Rectangle 1"/>
-          <p:cNvSpPr/>
-          <p:nvPr/>
-        </p:nvSpPr>
+      <p:pic>
+        <p:nvPicPr>
+          <p:cNvPr id="2" name="Picture 1" descr="bg_transmission_lines_deck.jpg"/>
+          <p:cNvPicPr>
+            <a:picLocks noChangeAspect="1"/>
+          </p:cNvPicPr>
+          <p:nvPr/>
+        </p:nvPicPr>
+        <p:blipFill>
+          <a:blip r:embed="rId2"/>
+          <a:stretch>
+            <a:fillRect/>
+          </a:stretch>
+        </p:blipFill>
         <p:spPr>
           <a:xfrm>
             <a:off x="0" y="0"/>
@@ -9890,11 +9746,137 @@
           <a:prstGeom prst="rect">
             <a:avLst/>
           </a:prstGeom>
+        </p:spPr>
+      </p:pic>
+      <p:sp>
+        <p:nvSpPr>
+          <p:cNvPr id="3" name="TextBox 2"/>
+          <p:cNvSpPr txBox="1"/>
+          <p:nvPr/>
+        </p:nvSpPr>
+        <p:spPr>
+          <a:xfrm>
+            <a:off x="731520" y="365760"/>
+            <a:ext cx="5486400" cy="320040"/>
+          </a:xfrm>
+          <a:prstGeom prst="rect">
+            <a:avLst/>
+          </a:prstGeom>
+          <a:noFill/>
+        </p:spPr>
+        <p:txBody>
+          <a:bodyPr wrap="square" lIns="0" tIns="0" rIns="0" bIns="0">
+            <a:spAutoFit/>
+          </a:bodyPr>
+          <a:lstStyle/>
+          <a:p>
+            <a:pPr>
+              <a:defRPr sz="950" b="1">
+                <a:solidFill>
+                  <a:srgbClr val="B6F542"/>
+                </a:solidFill>
+                <a:latin typeface="Consolas"/>
+              </a:defRPr>
+            </a:pPr>
+            <a:r>
+              <a:t>MACRO ECONOMIC CRISIS</a:t>
+            </a:r>
+          </a:p>
+        </p:txBody>
+      </p:sp>
+      <p:sp>
+        <p:nvSpPr>
+          <p:cNvPr id="4" name="TextBox 3"/>
+          <p:cNvSpPr txBox="1"/>
+          <p:nvPr/>
+        </p:nvSpPr>
+        <p:spPr>
+          <a:xfrm>
+            <a:off x="731520" y="658368"/>
+            <a:ext cx="10698480" cy="594360"/>
+          </a:xfrm>
+          <a:prstGeom prst="rect">
+            <a:avLst/>
+          </a:prstGeom>
+          <a:noFill/>
+        </p:spPr>
+        <p:txBody>
+          <a:bodyPr wrap="square" lIns="0" tIns="0" rIns="0" bIns="0">
+            <a:spAutoFit/>
+          </a:bodyPr>
+          <a:lstStyle/>
+          <a:p>
+            <a:pPr>
+              <a:defRPr sz="2200" b="1">
+                <a:solidFill>
+                  <a:srgbClr val="E1E4D2"/>
+                </a:solidFill>
+                <a:latin typeface="Trebuchet MS"/>
+              </a:defRPr>
+            </a:pPr>
+            <a:r>
+              <a:t>The Bleeding Grid: Pakistan's Power Sector in Numbers</a:t>
+            </a:r>
+          </a:p>
+        </p:txBody>
+      </p:sp>
+      <p:sp>
+        <p:nvSpPr>
+          <p:cNvPr id="5" name="TextBox 4"/>
+          <p:cNvSpPr txBox="1"/>
+          <p:nvPr/>
+        </p:nvSpPr>
+        <p:spPr>
+          <a:xfrm>
+            <a:off x="731520" y="1243584"/>
+            <a:ext cx="10698480" cy="365760"/>
+          </a:xfrm>
+          <a:prstGeom prst="rect">
+            <a:avLst/>
+          </a:prstGeom>
+          <a:noFill/>
+        </p:spPr>
+        <p:txBody>
+          <a:bodyPr wrap="square" lIns="0" tIns="0" rIns="0" bIns="0">
+            <a:spAutoFit/>
+          </a:bodyPr>
+          <a:lstStyle/>
+          <a:p>
+            <a:pPr>
+              <a:defRPr sz="1100">
+                <a:solidFill>
+                  <a:srgbClr val="A0A891"/>
+                </a:solidFill>
+                <a:latin typeface="Segoe UI"/>
+              </a:defRPr>
+            </a:pPr>
+            <a:r>
+              <a:t>10 Distribution Companies lose between 8% and 38% of distributed electricity annually</a:t>
+            </a:r>
+          </a:p>
+        </p:txBody>
+      </p:sp>
+      <p:sp>
+        <p:nvSpPr>
+          <p:cNvPr id="6" name="Rounded Rectangle 5"/>
+          <p:cNvSpPr/>
+          <p:nvPr/>
+        </p:nvSpPr>
+        <p:spPr>
+          <a:xfrm>
+            <a:off x="731520" y="1691640"/>
+            <a:ext cx="4754880" cy="4572000"/>
+          </a:xfrm>
+          <a:prstGeom prst="roundRect">
+            <a:avLst/>
+          </a:prstGeom>
           <a:solidFill>
-            <a:srgbClr val="11150A"/>
+            <a:srgbClr val="181D11"/>
           </a:solidFill>
-          <a:ln>
-            <a:noFill/>
+          <a:ln w="12700">
+            <a:solidFill>
+              <a:srgbClr val="2E3523"/>
+            </a:solidFill>
           </a:ln>
         </p:spPr>
         <p:style>
@@ -9921,159 +9903,6 @@
       </p:sp>
       <p:sp>
         <p:nvSpPr>
-          <p:cNvPr id="3" name="TextBox 2"/>
-          <p:cNvSpPr txBox="1"/>
-          <p:nvPr/>
-        </p:nvSpPr>
-        <p:spPr>
-          <a:xfrm>
-            <a:off x="731520" y="365760"/>
-            <a:ext cx="5486400" cy="320040"/>
-          </a:xfrm>
-          <a:prstGeom prst="rect">
-            <a:avLst/>
-          </a:prstGeom>
-          <a:noFill/>
-        </p:spPr>
-        <p:txBody>
-          <a:bodyPr wrap="square" lIns="0" tIns="0" rIns="0" bIns="0">
-            <a:spAutoFit/>
-          </a:bodyPr>
-          <a:lstStyle/>
-          <a:p>
-            <a:pPr>
-              <a:defRPr sz="950" b="1">
-                <a:solidFill>
-                  <a:srgbClr val="B6F542"/>
-                </a:solidFill>
-                <a:latin typeface="Consolas"/>
-              </a:defRPr>
-            </a:pPr>
-            <a:r>
-              <a:t>MACRO ECONOMIC CRISIS</a:t>
-            </a:r>
-          </a:p>
-        </p:txBody>
-      </p:sp>
-      <p:sp>
-        <p:nvSpPr>
-          <p:cNvPr id="4" name="TextBox 3"/>
-          <p:cNvSpPr txBox="1"/>
-          <p:nvPr/>
-        </p:nvSpPr>
-        <p:spPr>
-          <a:xfrm>
-            <a:off x="731520" y="658368"/>
-            <a:ext cx="10698480" cy="594360"/>
-          </a:xfrm>
-          <a:prstGeom prst="rect">
-            <a:avLst/>
-          </a:prstGeom>
-          <a:noFill/>
-        </p:spPr>
-        <p:txBody>
-          <a:bodyPr wrap="square" lIns="0" tIns="0" rIns="0" bIns="0">
-            <a:spAutoFit/>
-          </a:bodyPr>
-          <a:lstStyle/>
-          <a:p>
-            <a:pPr>
-              <a:defRPr sz="2200" b="1">
-                <a:solidFill>
-                  <a:srgbClr val="E1E4D2"/>
-                </a:solidFill>
-                <a:latin typeface="Trebuchet MS"/>
-              </a:defRPr>
-            </a:pPr>
-            <a:r>
-              <a:t>The Bleeding Grid: Pakistan's Power Sector in Numbers</a:t>
-            </a:r>
-          </a:p>
-        </p:txBody>
-      </p:sp>
-      <p:sp>
-        <p:nvSpPr>
-          <p:cNvPr id="5" name="TextBox 4"/>
-          <p:cNvSpPr txBox="1"/>
-          <p:nvPr/>
-        </p:nvSpPr>
-        <p:spPr>
-          <a:xfrm>
-            <a:off x="731520" y="1243584"/>
-            <a:ext cx="10698480" cy="365760"/>
-          </a:xfrm>
-          <a:prstGeom prst="rect">
-            <a:avLst/>
-          </a:prstGeom>
-          <a:noFill/>
-        </p:spPr>
-        <p:txBody>
-          <a:bodyPr wrap="square" lIns="0" tIns="0" rIns="0" bIns="0">
-            <a:spAutoFit/>
-          </a:bodyPr>
-          <a:lstStyle/>
-          <a:p>
-            <a:pPr>
-              <a:defRPr sz="1100">
-                <a:solidFill>
-                  <a:srgbClr val="A0A891"/>
-                </a:solidFill>
-                <a:latin typeface="Segoe UI"/>
-              </a:defRPr>
-            </a:pPr>
-            <a:r>
-              <a:t>10 Distribution Companies lose between 8% and 38% of distributed electricity annually</a:t>
-            </a:r>
-          </a:p>
-        </p:txBody>
-      </p:sp>
-      <p:sp>
-        <p:nvSpPr>
-          <p:cNvPr id="6" name="Rounded Rectangle 5"/>
-          <p:cNvSpPr/>
-          <p:nvPr/>
-        </p:nvSpPr>
-        <p:spPr>
-          <a:xfrm>
-            <a:off x="731520" y="1691640"/>
-            <a:ext cx="4754880" cy="4572000"/>
-          </a:xfrm>
-          <a:prstGeom prst="roundRect">
-            <a:avLst/>
-          </a:prstGeom>
-          <a:solidFill>
-            <a:srgbClr val="181D11"/>
-          </a:solidFill>
-          <a:ln w="12700">
-            <a:solidFill>
-              <a:srgbClr val="2E3523"/>
-            </a:solidFill>
-          </a:ln>
-        </p:spPr>
-        <p:style>
-          <a:lnRef idx="1">
-            <a:schemeClr val="accent1"/>
-          </a:lnRef>
-          <a:fillRef idx="3">
-            <a:schemeClr val="accent1"/>
-          </a:fillRef>
-          <a:effectRef idx="2">
-            <a:schemeClr val="accent1"/>
-          </a:effectRef>
-          <a:fontRef idx="minor">
-            <a:schemeClr val="lt1"/>
-          </a:fontRef>
-        </p:style>
-        <p:txBody>
-          <a:bodyPr rtlCol="0" anchor="ctr"/>
-          <a:lstStyle/>
-          <a:p>
-            <a:pPr algn="ctr"/>
-          </a:p>
-        </p:txBody>
-      </p:sp>
-      <p:sp>
-        <p:nvSpPr>
           <p:cNvPr id="7" name="TextBox 6"/>
           <p:cNvSpPr txBox="1"/>
           <p:nvPr/>
@@ -10192,7 +10021,7 @@
           <p:nvPr/>
         </p:nvPicPr>
         <p:blipFill>
-          <a:blip r:embed="rId2"/>
+          <a:blip r:embed="rId3"/>
           <a:stretch>
             <a:fillRect/>
           </a:stretch>
@@ -10225,12 +10054,20 @@
         <p:nvPr/>
       </p:nvGrpSpPr>
       <p:grpSpPr/>
-      <p:sp>
-        <p:nvSpPr>
-          <p:cNvPr id="2" name="Rectangle 1"/>
-          <p:cNvSpPr/>
-          <p:nvPr/>
-        </p:nvSpPr>
+      <p:pic>
+        <p:nvPicPr>
+          <p:cNvPr id="2" name="Picture 1" descr="bg_transmission_lines_deck.jpg"/>
+          <p:cNvPicPr>
+            <a:picLocks noChangeAspect="1"/>
+          </p:cNvPicPr>
+          <p:nvPr/>
+        </p:nvPicPr>
+        <p:blipFill>
+          <a:blip r:embed="rId2"/>
+          <a:stretch>
+            <a:fillRect/>
+          </a:stretch>
+        </p:blipFill>
         <p:spPr>
           <a:xfrm>
             <a:off x="0" y="0"/>
@@ -10239,35 +10076,8 @@
           <a:prstGeom prst="rect">
             <a:avLst/>
           </a:prstGeom>
-          <a:solidFill>
-            <a:srgbClr val="11150A"/>
-          </a:solidFill>
-          <a:ln>
-            <a:noFill/>
-          </a:ln>
-        </p:spPr>
-        <p:style>
-          <a:lnRef idx="1">
-            <a:schemeClr val="accent1"/>
-          </a:lnRef>
-          <a:fillRef idx="3">
-            <a:schemeClr val="accent1"/>
-          </a:fillRef>
-          <a:effectRef idx="2">
-            <a:schemeClr val="accent1"/>
-          </a:effectRef>
-          <a:fontRef idx="minor">
-            <a:schemeClr val="lt1"/>
-          </a:fontRef>
-        </p:style>
-        <p:txBody>
-          <a:bodyPr rtlCol="0" anchor="ctr"/>
-          <a:lstStyle/>
-          <a:p>
-            <a:pPr algn="ctr"/>
-          </a:p>
-        </p:txBody>
-      </p:sp>
+        </p:spPr>
+      </p:pic>
       <p:sp>
         <p:nvSpPr>
           <p:cNvPr id="3" name="TextBox 2"/>
@@ -10385,7 +10195,7 @@
           <p:nvPr/>
         </p:nvPicPr>
         <p:blipFill>
-          <a:blip r:embed="rId2"/>
+          <a:blip r:embed="rId3"/>
           <a:stretch>
             <a:fillRect/>
           </a:stretch>
@@ -10599,12 +10409,20 @@
         <p:nvPr/>
       </p:nvGrpSpPr>
       <p:grpSpPr/>
-      <p:sp>
-        <p:nvSpPr>
-          <p:cNvPr id="2" name="Rectangle 1"/>
-          <p:cNvSpPr/>
-          <p:nvPr/>
-        </p:nvSpPr>
+      <p:pic>
+        <p:nvPicPr>
+          <p:cNvPr id="2" name="Picture 1" descr="bg_transmission_lines_deck.jpg"/>
+          <p:cNvPicPr>
+            <a:picLocks noChangeAspect="1"/>
+          </p:cNvPicPr>
+          <p:nvPr/>
+        </p:nvPicPr>
+        <p:blipFill>
+          <a:blip r:embed="rId2"/>
+          <a:stretch>
+            <a:fillRect/>
+          </a:stretch>
+        </p:blipFill>
         <p:spPr>
           <a:xfrm>
             <a:off x="0" y="0"/>
@@ -10613,35 +10431,8 @@
           <a:prstGeom prst="rect">
             <a:avLst/>
           </a:prstGeom>
-          <a:solidFill>
-            <a:srgbClr val="11150A"/>
-          </a:solidFill>
-          <a:ln>
-            <a:noFill/>
-          </a:ln>
-        </p:spPr>
-        <p:style>
-          <a:lnRef idx="1">
-            <a:schemeClr val="accent1"/>
-          </a:lnRef>
-          <a:fillRef idx="3">
-            <a:schemeClr val="accent1"/>
-          </a:fillRef>
-          <a:effectRef idx="2">
-            <a:schemeClr val="accent1"/>
-          </a:effectRef>
-          <a:fontRef idx="minor">
-            <a:schemeClr val="lt1"/>
-          </a:fontRef>
-        </p:style>
-        <p:txBody>
-          <a:bodyPr rtlCol="0" anchor="ctr"/>
-          <a:lstStyle/>
-          <a:p>
-            <a:pPr algn="ctr"/>
-          </a:p>
-        </p:txBody>
-      </p:sp>
+        </p:spPr>
+      </p:pic>
       <p:sp>
         <p:nvSpPr>
           <p:cNvPr id="3" name="TextBox 2"/>
@@ -11161,12 +10952,20 @@
         <p:nvPr/>
       </p:nvGrpSpPr>
       <p:grpSpPr/>
-      <p:sp>
-        <p:nvSpPr>
-          <p:cNvPr id="2" name="Rectangle 1"/>
-          <p:cNvSpPr/>
-          <p:nvPr/>
-        </p:nvSpPr>
+      <p:pic>
+        <p:nvPicPr>
+          <p:cNvPr id="2" name="Picture 1" descr="bg_transmission_lines_deck.jpg"/>
+          <p:cNvPicPr>
+            <a:picLocks noChangeAspect="1"/>
+          </p:cNvPicPr>
+          <p:nvPr/>
+        </p:nvPicPr>
+        <p:blipFill>
+          <a:blip r:embed="rId2"/>
+          <a:stretch>
+            <a:fillRect/>
+          </a:stretch>
+        </p:blipFill>
         <p:spPr>
           <a:xfrm>
             <a:off x="0" y="0"/>
@@ -11175,35 +10974,8 @@
           <a:prstGeom prst="rect">
             <a:avLst/>
           </a:prstGeom>
-          <a:solidFill>
-            <a:srgbClr val="11150A"/>
-          </a:solidFill>
-          <a:ln>
-            <a:noFill/>
-          </a:ln>
-        </p:spPr>
-        <p:style>
-          <a:lnRef idx="1">
-            <a:schemeClr val="accent1"/>
-          </a:lnRef>
-          <a:fillRef idx="3">
-            <a:schemeClr val="accent1"/>
-          </a:fillRef>
-          <a:effectRef idx="2">
-            <a:schemeClr val="accent1"/>
-          </a:effectRef>
-          <a:fontRef idx="minor">
-            <a:schemeClr val="lt1"/>
-          </a:fontRef>
-        </p:style>
-        <p:txBody>
-          <a:bodyPr rtlCol="0" anchor="ctr"/>
-          <a:lstStyle/>
-          <a:p>
-            <a:pPr algn="ctr"/>
-          </a:p>
-        </p:txBody>
-      </p:sp>
+        </p:spPr>
+      </p:pic>
       <p:sp>
         <p:nvSpPr>
           <p:cNvPr id="3" name="TextBox 2"/>
@@ -11854,12 +11626,20 @@
         <p:nvPr/>
       </p:nvGrpSpPr>
       <p:grpSpPr/>
-      <p:sp>
-        <p:nvSpPr>
-          <p:cNvPr id="2" name="Rectangle 1"/>
-          <p:cNvSpPr/>
-          <p:nvPr/>
-        </p:nvSpPr>
+      <p:pic>
+        <p:nvPicPr>
+          <p:cNvPr id="2" name="Picture 1" descr="bg_transmission_lines_deck.jpg"/>
+          <p:cNvPicPr>
+            <a:picLocks noChangeAspect="1"/>
+          </p:cNvPicPr>
+          <p:nvPr/>
+        </p:nvPicPr>
+        <p:blipFill>
+          <a:blip r:embed="rId2"/>
+          <a:stretch>
+            <a:fillRect/>
+          </a:stretch>
+        </p:blipFill>
         <p:spPr>
           <a:xfrm>
             <a:off x="0" y="0"/>
@@ -11868,35 +11648,8 @@
           <a:prstGeom prst="rect">
             <a:avLst/>
           </a:prstGeom>
-          <a:solidFill>
-            <a:srgbClr val="11150A"/>
-          </a:solidFill>
-          <a:ln>
-            <a:noFill/>
-          </a:ln>
-        </p:spPr>
-        <p:style>
-          <a:lnRef idx="1">
-            <a:schemeClr val="accent1"/>
-          </a:lnRef>
-          <a:fillRef idx="3">
-            <a:schemeClr val="accent1"/>
-          </a:fillRef>
-          <a:effectRef idx="2">
-            <a:schemeClr val="accent1"/>
-          </a:effectRef>
-          <a:fontRef idx="minor">
-            <a:schemeClr val="lt1"/>
-          </a:fontRef>
-        </p:style>
-        <p:txBody>
-          <a:bodyPr rtlCol="0" anchor="ctr"/>
-          <a:lstStyle/>
-          <a:p>
-            <a:pPr algn="ctr"/>
-          </a:p>
-        </p:txBody>
-      </p:sp>
+        </p:spPr>
+      </p:pic>
       <p:sp>
         <p:nvSpPr>
           <p:cNvPr id="3" name="TextBox 2"/>
@@ -12014,7 +11767,7 @@
           <p:nvPr/>
         </p:nvPicPr>
         <p:blipFill>
-          <a:blip r:embed="rId2"/>
+          <a:blip r:embed="rId3"/>
           <a:stretch>
             <a:fillRect/>
           </a:stretch>
@@ -12228,12 +11981,20 @@
         <p:nvPr/>
       </p:nvGrpSpPr>
       <p:grpSpPr/>
-      <p:sp>
-        <p:nvSpPr>
-          <p:cNvPr id="2" name="Rectangle 1"/>
-          <p:cNvSpPr/>
-          <p:nvPr/>
-        </p:nvSpPr>
+      <p:pic>
+        <p:nvPicPr>
+          <p:cNvPr id="2" name="Picture 1" descr="bg_transmission_lines_deck.jpg"/>
+          <p:cNvPicPr>
+            <a:picLocks noChangeAspect="1"/>
+          </p:cNvPicPr>
+          <p:nvPr/>
+        </p:nvPicPr>
+        <p:blipFill>
+          <a:blip r:embed="rId2"/>
+          <a:stretch>
+            <a:fillRect/>
+          </a:stretch>
+        </p:blipFill>
         <p:spPr>
           <a:xfrm>
             <a:off x="0" y="0"/>
@@ -12242,35 +12003,8 @@
           <a:prstGeom prst="rect">
             <a:avLst/>
           </a:prstGeom>
-          <a:solidFill>
-            <a:srgbClr val="11150A"/>
-          </a:solidFill>
-          <a:ln>
-            <a:noFill/>
-          </a:ln>
-        </p:spPr>
-        <p:style>
-          <a:lnRef idx="1">
-            <a:schemeClr val="accent1"/>
-          </a:lnRef>
-          <a:fillRef idx="3">
-            <a:schemeClr val="accent1"/>
-          </a:fillRef>
-          <a:effectRef idx="2">
-            <a:schemeClr val="accent1"/>
-          </a:effectRef>
-          <a:fontRef idx="minor">
-            <a:schemeClr val="lt1"/>
-          </a:fontRef>
-        </p:style>
-        <p:txBody>
-          <a:bodyPr rtlCol="0" anchor="ctr"/>
-          <a:lstStyle/>
-          <a:p>
-            <a:pPr algn="ctr"/>
-          </a:p>
-        </p:txBody>
-      </p:sp>
+        </p:spPr>
+      </p:pic>
       <p:sp>
         <p:nvSpPr>
           <p:cNvPr id="3" name="TextBox 2"/>
@@ -12388,7 +12122,7 @@
           <p:nvPr/>
         </p:nvPicPr>
         <p:blipFill>
-          <a:blip r:embed="rId2"/>
+          <a:blip r:embed="rId3"/>
           <a:stretch>
             <a:fillRect/>
           </a:stretch>
@@ -12602,12 +12336,20 @@
         <p:nvPr/>
       </p:nvGrpSpPr>
       <p:grpSpPr/>
-      <p:sp>
-        <p:nvSpPr>
-          <p:cNvPr id="2" name="Rectangle 1"/>
-          <p:cNvSpPr/>
-          <p:nvPr/>
-        </p:nvSpPr>
+      <p:pic>
+        <p:nvPicPr>
+          <p:cNvPr id="2" name="Picture 1" descr="bg_transmission_lines_deck.jpg"/>
+          <p:cNvPicPr>
+            <a:picLocks noChangeAspect="1"/>
+          </p:cNvPicPr>
+          <p:nvPr/>
+        </p:nvPicPr>
+        <p:blipFill>
+          <a:blip r:embed="rId2"/>
+          <a:stretch>
+            <a:fillRect/>
+          </a:stretch>
+        </p:blipFill>
         <p:spPr>
           <a:xfrm>
             <a:off x="0" y="0"/>
@@ -12616,35 +12358,8 @@
           <a:prstGeom prst="rect">
             <a:avLst/>
           </a:prstGeom>
-          <a:solidFill>
-            <a:srgbClr val="11150A"/>
-          </a:solidFill>
-          <a:ln>
-            <a:noFill/>
-          </a:ln>
-        </p:spPr>
-        <p:style>
-          <a:lnRef idx="1">
-            <a:schemeClr val="accent1"/>
-          </a:lnRef>
-          <a:fillRef idx="3">
-            <a:schemeClr val="accent1"/>
-          </a:fillRef>
-          <a:effectRef idx="2">
-            <a:schemeClr val="accent1"/>
-          </a:effectRef>
-          <a:fontRef idx="minor">
-            <a:schemeClr val="lt1"/>
-          </a:fontRef>
-        </p:style>
-        <p:txBody>
-          <a:bodyPr rtlCol="0" anchor="ctr"/>
-          <a:lstStyle/>
-          <a:p>
-            <a:pPr algn="ctr"/>
-          </a:p>
-        </p:txBody>
-      </p:sp>
+        </p:spPr>
+      </p:pic>
       <p:sp>
         <p:nvSpPr>
           <p:cNvPr id="3" name="TextBox 2"/>
@@ -13258,12 +12973,20 @@
         <p:nvPr/>
       </p:nvGrpSpPr>
       <p:grpSpPr/>
-      <p:sp>
-        <p:nvSpPr>
-          <p:cNvPr id="2" name="Rectangle 1"/>
-          <p:cNvSpPr/>
-          <p:nvPr/>
-        </p:nvSpPr>
+      <p:pic>
+        <p:nvPicPr>
+          <p:cNvPr id="2" name="Picture 1" descr="bg_transmission_lines_deck.jpg"/>
+          <p:cNvPicPr>
+            <a:picLocks noChangeAspect="1"/>
+          </p:cNvPicPr>
+          <p:nvPr/>
+        </p:nvPicPr>
+        <p:blipFill>
+          <a:blip r:embed="rId2"/>
+          <a:stretch>
+            <a:fillRect/>
+          </a:stretch>
+        </p:blipFill>
         <p:spPr>
           <a:xfrm>
             <a:off x="0" y="0"/>
@@ -13272,11 +12995,137 @@
           <a:prstGeom prst="rect">
             <a:avLst/>
           </a:prstGeom>
+        </p:spPr>
+      </p:pic>
+      <p:sp>
+        <p:nvSpPr>
+          <p:cNvPr id="3" name="TextBox 2"/>
+          <p:cNvSpPr txBox="1"/>
+          <p:nvPr/>
+        </p:nvSpPr>
+        <p:spPr>
+          <a:xfrm>
+            <a:off x="731520" y="365760"/>
+            <a:ext cx="5486400" cy="320040"/>
+          </a:xfrm>
+          <a:prstGeom prst="rect">
+            <a:avLst/>
+          </a:prstGeom>
+          <a:noFill/>
+        </p:spPr>
+        <p:txBody>
+          <a:bodyPr wrap="square" lIns="0" tIns="0" rIns="0" bIns="0">
+            <a:spAutoFit/>
+          </a:bodyPr>
+          <a:lstStyle/>
+          <a:p>
+            <a:pPr>
+              <a:defRPr sz="950" b="1">
+                <a:solidFill>
+                  <a:srgbClr val="B6F542"/>
+                </a:solidFill>
+                <a:latin typeface="Consolas"/>
+              </a:defRPr>
+            </a:pPr>
+            <a:r>
+              <a:t>TELEMETRY SIGNATURES</a:t>
+            </a:r>
+          </a:p>
+        </p:txBody>
+      </p:sp>
+      <p:sp>
+        <p:nvSpPr>
+          <p:cNvPr id="4" name="TextBox 3"/>
+          <p:cNvSpPr txBox="1"/>
+          <p:nvPr/>
+        </p:nvSpPr>
+        <p:spPr>
+          <a:xfrm>
+            <a:off x="731520" y="658368"/>
+            <a:ext cx="10698480" cy="594360"/>
+          </a:xfrm>
+          <a:prstGeom prst="rect">
+            <a:avLst/>
+          </a:prstGeom>
+          <a:noFill/>
+        </p:spPr>
+        <p:txBody>
+          <a:bodyPr wrap="square" lIns="0" tIns="0" rIns="0" bIns="0">
+            <a:spAutoFit/>
+          </a:bodyPr>
+          <a:lstStyle/>
+          <a:p>
+            <a:pPr>
+              <a:defRPr sz="2200" b="1">
+                <a:solidFill>
+                  <a:srgbClr val="E1E4D2"/>
+                </a:solidFill>
+                <a:latin typeface="Trebuchet MS"/>
+              </a:defRPr>
+            </a:pPr>
+            <a:r>
+              <a:t>24-Hour Diurnal Curves: Unmasking Peak Shavers &amp; Solar Ducks</a:t>
+            </a:r>
+          </a:p>
+        </p:txBody>
+      </p:sp>
+      <p:sp>
+        <p:nvSpPr>
+          <p:cNvPr id="5" name="TextBox 4"/>
+          <p:cNvSpPr txBox="1"/>
+          <p:nvPr/>
+        </p:nvSpPr>
+        <p:spPr>
+          <a:xfrm>
+            <a:off x="731520" y="1243584"/>
+            <a:ext cx="10698480" cy="365760"/>
+          </a:xfrm>
+          <a:prstGeom prst="rect">
+            <a:avLst/>
+          </a:prstGeom>
+          <a:noFill/>
+        </p:spPr>
+        <p:txBody>
+          <a:bodyPr wrap="square" lIns="0" tIns="0" rIns="0" bIns="0">
+            <a:spAutoFit/>
+          </a:bodyPr>
+          <a:lstStyle/>
+          <a:p>
+            <a:pPr>
+              <a:defRPr sz="1100">
+                <a:solidFill>
+                  <a:srgbClr val="A0A891"/>
+                </a:solidFill>
+                <a:latin typeface="Segoe UI"/>
+              </a:defRPr>
+            </a:pPr>
+            <a:r>
+              <a:t>High-frequency interval resolution separates legitimate clean energy from criminal bypass</a:t>
+            </a:r>
+          </a:p>
+        </p:txBody>
+      </p:sp>
+      <p:sp>
+        <p:nvSpPr>
+          <p:cNvPr id="6" name="Rounded Rectangle 5"/>
+          <p:cNvSpPr/>
+          <p:nvPr/>
+        </p:nvSpPr>
+        <p:spPr>
+          <a:xfrm>
+            <a:off x="731520" y="1691640"/>
+            <a:ext cx="4754880" cy="4572000"/>
+          </a:xfrm>
+          <a:prstGeom prst="roundRect">
+            <a:avLst/>
+          </a:prstGeom>
           <a:solidFill>
-            <a:srgbClr val="11150A"/>
+            <a:srgbClr val="181D11"/>
           </a:solidFill>
-          <a:ln>
-            <a:noFill/>
+          <a:ln w="12700">
+            <a:solidFill>
+              <a:srgbClr val="2E3523"/>
+            </a:solidFill>
           </a:ln>
         </p:spPr>
         <p:style>
@@ -13303,159 +13152,6 @@
       </p:sp>
       <p:sp>
         <p:nvSpPr>
-          <p:cNvPr id="3" name="TextBox 2"/>
-          <p:cNvSpPr txBox="1"/>
-          <p:nvPr/>
-        </p:nvSpPr>
-        <p:spPr>
-          <a:xfrm>
-            <a:off x="731520" y="365760"/>
-            <a:ext cx="5486400" cy="320040"/>
-          </a:xfrm>
-          <a:prstGeom prst="rect">
-            <a:avLst/>
-          </a:prstGeom>
-          <a:noFill/>
-        </p:spPr>
-        <p:txBody>
-          <a:bodyPr wrap="square" lIns="0" tIns="0" rIns="0" bIns="0">
-            <a:spAutoFit/>
-          </a:bodyPr>
-          <a:lstStyle/>
-          <a:p>
-            <a:pPr>
-              <a:defRPr sz="950" b="1">
-                <a:solidFill>
-                  <a:srgbClr val="B6F542"/>
-                </a:solidFill>
-                <a:latin typeface="Consolas"/>
-              </a:defRPr>
-            </a:pPr>
-            <a:r>
-              <a:t>TELEMETRY SIGNATURES</a:t>
-            </a:r>
-          </a:p>
-        </p:txBody>
-      </p:sp>
-      <p:sp>
-        <p:nvSpPr>
-          <p:cNvPr id="4" name="TextBox 3"/>
-          <p:cNvSpPr txBox="1"/>
-          <p:nvPr/>
-        </p:nvSpPr>
-        <p:spPr>
-          <a:xfrm>
-            <a:off x="731520" y="658368"/>
-            <a:ext cx="10698480" cy="594360"/>
-          </a:xfrm>
-          <a:prstGeom prst="rect">
-            <a:avLst/>
-          </a:prstGeom>
-          <a:noFill/>
-        </p:spPr>
-        <p:txBody>
-          <a:bodyPr wrap="square" lIns="0" tIns="0" rIns="0" bIns="0">
-            <a:spAutoFit/>
-          </a:bodyPr>
-          <a:lstStyle/>
-          <a:p>
-            <a:pPr>
-              <a:defRPr sz="2200" b="1">
-                <a:solidFill>
-                  <a:srgbClr val="E1E4D2"/>
-                </a:solidFill>
-                <a:latin typeface="Trebuchet MS"/>
-              </a:defRPr>
-            </a:pPr>
-            <a:r>
-              <a:t>24-Hour Diurnal Curves: Unmasking Peak Shavers &amp; Solar Ducks</a:t>
-            </a:r>
-          </a:p>
-        </p:txBody>
-      </p:sp>
-      <p:sp>
-        <p:nvSpPr>
-          <p:cNvPr id="5" name="TextBox 4"/>
-          <p:cNvSpPr txBox="1"/>
-          <p:nvPr/>
-        </p:nvSpPr>
-        <p:spPr>
-          <a:xfrm>
-            <a:off x="731520" y="1243584"/>
-            <a:ext cx="10698480" cy="365760"/>
-          </a:xfrm>
-          <a:prstGeom prst="rect">
-            <a:avLst/>
-          </a:prstGeom>
-          <a:noFill/>
-        </p:spPr>
-        <p:txBody>
-          <a:bodyPr wrap="square" lIns="0" tIns="0" rIns="0" bIns="0">
-            <a:spAutoFit/>
-          </a:bodyPr>
-          <a:lstStyle/>
-          <a:p>
-            <a:pPr>
-              <a:defRPr sz="1100">
-                <a:solidFill>
-                  <a:srgbClr val="A0A891"/>
-                </a:solidFill>
-                <a:latin typeface="Segoe UI"/>
-              </a:defRPr>
-            </a:pPr>
-            <a:r>
-              <a:t>High-frequency interval resolution separates legitimate clean energy from criminal bypass</a:t>
-            </a:r>
-          </a:p>
-        </p:txBody>
-      </p:sp>
-      <p:sp>
-        <p:nvSpPr>
-          <p:cNvPr id="6" name="Rounded Rectangle 5"/>
-          <p:cNvSpPr/>
-          <p:nvPr/>
-        </p:nvSpPr>
-        <p:spPr>
-          <a:xfrm>
-            <a:off x="731520" y="1691640"/>
-            <a:ext cx="4754880" cy="4572000"/>
-          </a:xfrm>
-          <a:prstGeom prst="roundRect">
-            <a:avLst/>
-          </a:prstGeom>
-          <a:solidFill>
-            <a:srgbClr val="181D11"/>
-          </a:solidFill>
-          <a:ln w="12700">
-            <a:solidFill>
-              <a:srgbClr val="2E3523"/>
-            </a:solidFill>
-          </a:ln>
-        </p:spPr>
-        <p:style>
-          <a:lnRef idx="1">
-            <a:schemeClr val="accent1"/>
-          </a:lnRef>
-          <a:fillRef idx="3">
-            <a:schemeClr val="accent1"/>
-          </a:fillRef>
-          <a:effectRef idx="2">
-            <a:schemeClr val="accent1"/>
-          </a:effectRef>
-          <a:fontRef idx="minor">
-            <a:schemeClr val="lt1"/>
-          </a:fontRef>
-        </p:style>
-        <p:txBody>
-          <a:bodyPr rtlCol="0" anchor="ctr"/>
-          <a:lstStyle/>
-          <a:p>
-            <a:pPr algn="ctr"/>
-          </a:p>
-        </p:txBody>
-      </p:sp>
-      <p:sp>
-        <p:nvSpPr>
           <p:cNvPr id="7" name="TextBox 6"/>
           <p:cNvSpPr txBox="1"/>
           <p:nvPr/>
@@ -13599,7 +13295,7 @@
           <p:nvPr/>
         </p:nvPicPr>
         <p:blipFill>
-          <a:blip r:embed="rId2"/>
+          <a:blip r:embed="rId3"/>
           <a:stretch>
             <a:fillRect/>
           </a:stretch>

</xml_diff>